<commit_message>
sd-11-002..005: source-map read flags; scope replication claim; single-leader zero-loss needs acknowledged replication
Co-Authored-By: Claude Sonnet 5.5 <noreply@anthropic.com>
Claude-Session: https://claude.ai/code/session_0121Z35eF2EmPsW9asDgHWsZ
</commit_message>
<xml_diff>
--- a/system-design-101/vi/lessons/sd-11-002/slides/sd-11-002.pptx
+++ b/system-design-101/vi/lessons/sd-11-002/slides/sd-11-002.pptx
@@ -9265,6 +9265,61 @@
               <a:t> chậm</a:t>
             </a:r>
             <a:r>
+              <a:rPr lang="en-US" sz="2700" dirty="0" spc="-3" kern="0">
+                <a:solidFill>
+                  <a:srgbClr val="F3EEE3"/>
+                </a:solidFill>
+                <a:latin typeface="Be Vietnam Pro" pitchFamily="34" charset="0"/>
+                <a:ea typeface="Be Vietnam Pro" pitchFamily="34" charset="-122"/>
+                <a:cs typeface="Be Vietnam Pro" pitchFamily="34" charset="-120"/>
+              </a:rPr>
+              <a:t> hơn.</a:t>
+            </a:r>
+            <a:r>
+              <a:rPr lang="en-US" sz="2700" dirty="0" spc="-2" kern="0">
+                <a:solidFill>
+                  <a:srgbClr val="F3EEE3"/>
+                </a:solidFill>
+                <a:latin typeface="Be Vietnam Pro" pitchFamily="34" charset="0"/>
+                <a:ea typeface="Be Vietnam Pro" pitchFamily="34" charset="-122"/>
+                <a:cs typeface="Be Vietnam Pro" pitchFamily="34" charset="-120"/>
+              </a:rPr>
+              <a:t> Kiểu</a:t>
+            </a:r>
+            <a:r>
+              <a:rPr lang="en-US" sz="2700" dirty="0" spc="-7" kern="0">
+                <a:solidFill>
+                  <a:srgbClr val="F3EEE3"/>
+                </a:solidFill>
+                <a:latin typeface="Be Vietnam Pro" pitchFamily="34" charset="0"/>
+                <a:ea typeface="Be Vietnam Pro" pitchFamily="34" charset="-122"/>
+                <a:cs typeface="Be Vietnam Pro" pitchFamily="34" charset="-120"/>
+              </a:rPr>
+              <a:t> một</a:t>
+            </a:r>
+            <a:r>
+              <a:rPr lang="en-US" sz="2700" dirty="0" spc="-6" kern="0">
+                <a:solidFill>
+                  <a:srgbClr val="F3EEE3"/>
+                </a:solidFill>
+                <a:latin typeface="Be Vietnam Pro" pitchFamily="34" charset="0"/>
+                <a:ea typeface="Be Vietnam Pro" pitchFamily="34" charset="-122"/>
+                <a:cs typeface="Be Vietnam Pro" pitchFamily="34" charset="-120"/>
+              </a:rPr>
+              <a:t> bản</a:t>
+            </a:r>
+            <a:r>
+              <a:rPr lang="en-US" sz="2700" dirty="0" spc="-2" kern="0">
+                <a:solidFill>
+                  <a:srgbClr val="F3EEE3"/>
+                </a:solidFill>
+                <a:latin typeface="Be Vietnam Pro" pitchFamily="34" charset="0"/>
+                <a:ea typeface="Be Vietnam Pro" pitchFamily="34" charset="-122"/>
+                <a:cs typeface="Be Vietnam Pro" pitchFamily="34" charset="-120"/>
+              </a:rPr>
+              <a:t> chính:</a:t>
+            </a:r>
+            <a:r>
               <a:rPr lang="en-US" sz="2700" dirty="0" spc="-1" kern="0">
                 <a:solidFill>
                   <a:srgbClr val="F3EEE3"/>
@@ -9273,7 +9328,18 @@
                 <a:ea typeface="Be Vietnam Pro" pitchFamily="34" charset="-122"/>
                 <a:cs typeface="Be Vietnam Pro" pitchFamily="34" charset="-120"/>
               </a:rPr>
-              <a:t> hơn;</a:t>
+              <a:t> ghi</a:t>
+            </a:r>
+            <a:r>
+              <a:rPr lang="en-US" sz="2700" dirty="0" spc="-2" kern="0">
+                <a:solidFill>
+                  <a:srgbClr val="F3EEE3"/>
+                </a:solidFill>
+                <a:latin typeface="Be Vietnam Pro" pitchFamily="34" charset="0"/>
+                <a:ea typeface="Be Vietnam Pro" pitchFamily="34" charset="-122"/>
+                <a:cs typeface="Be Vietnam Pro" pitchFamily="34" charset="-120"/>
+              </a:rPr>
+              <a:t> không</a:t>
             </a:r>
             <a:r>
               <a:rPr lang="en-US" sz="2700" dirty="0" spc="-3" kern="0">
@@ -9284,18 +9350,7 @@
                 <a:ea typeface="Be Vietnam Pro" pitchFamily="34" charset="-122"/>
                 <a:cs typeface="Be Vietnam Pro" pitchFamily="34" charset="-120"/>
               </a:rPr>
-              <a:t> việc</a:t>
-            </a:r>
-            <a:r>
-              <a:rPr lang="en-US" sz="2700" dirty="0" spc="-1" kern="0">
-                <a:solidFill>
-                  <a:srgbClr val="F3EEE3"/>
-                </a:solidFill>
-                <a:latin typeface="Be Vietnam Pro" pitchFamily="34" charset="0"/>
-                <a:ea typeface="Be Vietnam Pro" pitchFamily="34" charset="-122"/>
-                <a:cs typeface="Be Vietnam Pro" pitchFamily="34" charset="-120"/>
-              </a:rPr>
-              <a:t> ghi</a:t>
+              <a:t> nhanh</a:t>
             </a:r>
             <a:r>
               <a:rPr lang="en-US" sz="2700" dirty="0" spc="-2" kern="0">
@@ -9306,18 +9361,7 @@
                 <a:ea typeface="Be Vietnam Pro" pitchFamily="34" charset="-122"/>
                 <a:cs typeface="Be Vietnam Pro" pitchFamily="34" charset="-120"/>
               </a:rPr>
-              <a:t> không</a:t>
-            </a:r>
-            <a:r>
-              <a:rPr lang="en-US" sz="2700" dirty="0" spc="-3" kern="0">
-                <a:solidFill>
-                  <a:srgbClr val="F3EEE3"/>
-                </a:solidFill>
-                <a:latin typeface="Be Vietnam Pro" pitchFamily="34" charset="0"/>
-                <a:ea typeface="Be Vietnam Pro" pitchFamily="34" charset="-122"/>
-                <a:cs typeface="Be Vietnam Pro" pitchFamily="34" charset="-120"/>
-              </a:rPr>
-              <a:t> nhanh hơn</a:t>
+              <a:t> hơn.</a:t>
             </a:r>
             <a:endParaRPr lang="en-US" sz="2700" dirty="0"/>
           </a:p>

</xml_diff>